<commit_message>
docs: refine project status slide layout
Co-authored-by: 程序员鱼皮 <592789970@qq.com>
</commit_message>
<xml_diff>
--- a/docs/reports/project-status-2026-07-23.pptx
+++ b/docs/reports/project-status-2026-07-23.pptx
@@ -2634,7 +2634,7 @@
         </p:nvSpPr>
         <p:spPr>
           <a:xfrm>
-            <a:off x="9235440" y="6080760"/>
+            <a:off x="9235440" y="5943600"/>
             <a:ext cx="1828800" cy="201168"/>
           </a:xfrm>
           <a:prstGeom prst="rect">
@@ -2970,8 +2970,8 @@
         </p:nvSpPr>
         <p:spPr>
           <a:xfrm>
-            <a:off x="731520" y="3182112"/>
-            <a:ext cx="2944368" cy="1627632"/>
+            <a:off x="731520" y="3273552"/>
+            <a:ext cx="2944368" cy="1417320"/>
           </a:xfrm>
           <a:prstGeom prst="roundRect">
             <a:avLst/>
@@ -3004,7 +3004,7 @@
         </p:nvSpPr>
         <p:spPr>
           <a:xfrm>
-            <a:off x="987552" y="3429000"/>
+            <a:off x="987552" y="3493008"/>
             <a:ext cx="457200" cy="310896"/>
           </a:xfrm>
           <a:prstGeom prst="rect">
@@ -3045,7 +3045,7 @@
         </p:nvSpPr>
         <p:spPr>
           <a:xfrm>
-            <a:off x="1527048" y="3401568"/>
+            <a:off x="1527048" y="3465576"/>
             <a:ext cx="1371600" cy="329184"/>
           </a:xfrm>
           <a:prstGeom prst="rect">
@@ -3086,17 +3086,17 @@
         </p:nvSpPr>
         <p:spPr>
           <a:xfrm>
-            <a:off x="987552" y="3931920"/>
-            <a:ext cx="2423160" cy="475488"/>
-          </a:xfrm>
-          <a:prstGeom prst="rect">
-            <a:avLst/>
-          </a:prstGeom>
-          <a:noFill/>
-          <a:ln/>
-        </p:spPr>
-        <p:txBody>
-          <a:bodyPr wrap="square" lIns="0" tIns="0" rIns="0" bIns="0" rtlCol="0" anchor="t">
+            <a:off x="987552" y="3913632"/>
+            <a:ext cx="2423160" cy="438912"/>
+          </a:xfrm>
+          <a:prstGeom prst="rect">
+            <a:avLst/>
+          </a:prstGeom>
+          <a:noFill/>
+          <a:ln/>
+        </p:spPr>
+        <p:txBody>
+          <a:bodyPr wrap="square" lIns="0" tIns="0" rIns="0" bIns="0" rtlCol="0" anchor="ctr">
             <a:normAutofit/>
           </a:bodyPr>
           <a:lstStyle/>
@@ -3127,8 +3127,8 @@
         </p:nvSpPr>
         <p:spPr>
           <a:xfrm>
-            <a:off x="4041648" y="3182112"/>
-            <a:ext cx="2944368" cy="1627632"/>
+            <a:off x="4041648" y="3273552"/>
+            <a:ext cx="2944368" cy="1417320"/>
           </a:xfrm>
           <a:prstGeom prst="roundRect">
             <a:avLst/>
@@ -3161,7 +3161,7 @@
         </p:nvSpPr>
         <p:spPr>
           <a:xfrm>
-            <a:off x="4297680" y="3429000"/>
+            <a:off x="4297680" y="3493008"/>
             <a:ext cx="457200" cy="310896"/>
           </a:xfrm>
           <a:prstGeom prst="rect">
@@ -3202,7 +3202,7 @@
         </p:nvSpPr>
         <p:spPr>
           <a:xfrm>
-            <a:off x="4837176" y="3401568"/>
+            <a:off x="4837176" y="3465576"/>
             <a:ext cx="1371600" cy="329184"/>
           </a:xfrm>
           <a:prstGeom prst="rect">
@@ -3243,17 +3243,17 @@
         </p:nvSpPr>
         <p:spPr>
           <a:xfrm>
-            <a:off x="4297680" y="3931920"/>
-            <a:ext cx="2423160" cy="475488"/>
-          </a:xfrm>
-          <a:prstGeom prst="rect">
-            <a:avLst/>
-          </a:prstGeom>
-          <a:noFill/>
-          <a:ln/>
-        </p:spPr>
-        <p:txBody>
-          <a:bodyPr wrap="square" lIns="0" tIns="0" rIns="0" bIns="0" rtlCol="0" anchor="t">
+            <a:off x="4297680" y="3913632"/>
+            <a:ext cx="2423160" cy="438912"/>
+          </a:xfrm>
+          <a:prstGeom prst="rect">
+            <a:avLst/>
+          </a:prstGeom>
+          <a:noFill/>
+          <a:ln/>
+        </p:spPr>
+        <p:txBody>
+          <a:bodyPr wrap="square" lIns="0" tIns="0" rIns="0" bIns="0" rtlCol="0" anchor="ctr">
             <a:normAutofit/>
           </a:bodyPr>
           <a:lstStyle/>
@@ -3284,8 +3284,8 @@
         </p:nvSpPr>
         <p:spPr>
           <a:xfrm>
-            <a:off x="7351776" y="3182112"/>
-            <a:ext cx="2944368" cy="1627632"/>
+            <a:off x="7351776" y="3273552"/>
+            <a:ext cx="2944368" cy="1417320"/>
           </a:xfrm>
           <a:prstGeom prst="roundRect">
             <a:avLst/>
@@ -3318,7 +3318,7 @@
         </p:nvSpPr>
         <p:spPr>
           <a:xfrm>
-            <a:off x="7607808" y="3429000"/>
+            <a:off x="7607808" y="3493008"/>
             <a:ext cx="457200" cy="310896"/>
           </a:xfrm>
           <a:prstGeom prst="rect">
@@ -3359,7 +3359,7 @@
         </p:nvSpPr>
         <p:spPr>
           <a:xfrm>
-            <a:off x="8147304" y="3401568"/>
+            <a:off x="8147304" y="3465576"/>
             <a:ext cx="1371600" cy="329184"/>
           </a:xfrm>
           <a:prstGeom prst="rect">
@@ -3400,17 +3400,17 @@
         </p:nvSpPr>
         <p:spPr>
           <a:xfrm>
-            <a:off x="7607808" y="3931920"/>
-            <a:ext cx="2423160" cy="475488"/>
-          </a:xfrm>
-          <a:prstGeom prst="rect">
-            <a:avLst/>
-          </a:prstGeom>
-          <a:noFill/>
-          <a:ln/>
-        </p:spPr>
-        <p:txBody>
-          <a:bodyPr wrap="square" lIns="0" tIns="0" rIns="0" bIns="0" rtlCol="0" anchor="t">
+            <a:off x="7607808" y="3913632"/>
+            <a:ext cx="2423160" cy="438912"/>
+          </a:xfrm>
+          <a:prstGeom prst="rect">
+            <a:avLst/>
+          </a:prstGeom>
+          <a:noFill/>
+          <a:ln/>
+        </p:spPr>
+        <p:txBody>
+          <a:bodyPr wrap="square" lIns="0" tIns="0" rIns="0" bIns="0" rtlCol="0" anchor="ctr">
             <a:normAutofit/>
           </a:bodyPr>
           <a:lstStyle/>
@@ -4175,9 +4175,9 @@
               <a:buNone/>
             </a:pPr>
             <a:r>
-              <a:rPr lang="en-US" sz="900" dirty="0">
-                <a:solidFill>
-                  <a:srgbClr val="6B7C8F"/>
+              <a:rPr lang="en-US" sz="950" dirty="0">
+                <a:solidFill>
+                  <a:srgbClr val="334E68"/>
                 </a:solidFill>
                 <a:latin typeface="Noto Sans" pitchFamily="34" charset="0"/>
                 <a:ea typeface="Noto Sans" pitchFamily="34" charset="-122"/>
@@ -4185,7 +4185,7 @@
               </a:rPr>
               <a:t>common / model / client / user / app / ai / screenshot</a:t>
             </a:r>
-            <a:endParaRPr lang="en-US" sz="900" dirty="0"/>
+            <a:endParaRPr lang="en-US" sz="950" dirty="0"/>
           </a:p>
         </p:txBody>
       </p:sp>
@@ -4357,9 +4357,9 @@
               <a:buNone/>
             </a:pPr>
             <a:r>
-              <a:rPr lang="en-US" sz="900" dirty="0">
-                <a:solidFill>
-                  <a:srgbClr val="6B7C8F"/>
+              <a:rPr lang="en-US" sz="950" dirty="0">
+                <a:solidFill>
+                  <a:srgbClr val="334E68"/>
                 </a:solidFill>
                 <a:latin typeface="Noto Sans" pitchFamily="34" charset="0"/>
                 <a:ea typeface="Noto Sans" pitchFamily="34" charset="-122"/>
@@ -4367,7 +4367,7 @@
               </a:rPr>
               <a:t>单体与微服务代码合计</a:t>
             </a:r>
-            <a:endParaRPr lang="en-US" sz="900" dirty="0"/>
+            <a:endParaRPr lang="en-US" sz="950" dirty="0"/>
           </a:p>
         </p:txBody>
       </p:sp>
@@ -4539,9 +4539,9 @@
               <a:buNone/>
             </a:pPr>
             <a:r>
-              <a:rPr lang="en-US" sz="900" dirty="0">
-                <a:solidFill>
-                  <a:srgbClr val="6B7C8F"/>
+              <a:rPr lang="en-US" sz="950" dirty="0">
+                <a:solidFill>
+                  <a:srgbClr val="334E68"/>
                 </a:solidFill>
                 <a:latin typeface="Noto Sans" pitchFamily="34" charset="0"/>
                 <a:ea typeface="Noto Sans" pitchFamily="34" charset="-122"/>
@@ -4549,7 +4549,7 @@
               </a:rPr>
               <a:t>Vue 3 + TypeScript + Ant Design Vue</a:t>
             </a:r>
-            <a:endParaRPr lang="en-US" sz="900" dirty="0"/>
+            <a:endParaRPr lang="en-US" sz="950" dirty="0"/>
           </a:p>
         </p:txBody>
       </p:sp>
@@ -4721,9 +4721,9 @@
               <a:buNone/>
             </a:pPr>
             <a:r>
-              <a:rPr lang="en-US" sz="900" dirty="0">
-                <a:solidFill>
-                  <a:srgbClr val="6B7C8F"/>
+              <a:rPr lang="en-US" sz="950" dirty="0">
+                <a:solidFill>
+                  <a:srgbClr val="334E68"/>
                 </a:solidFill>
                 <a:latin typeface="Noto Sans" pitchFamily="34" charset="0"/>
                 <a:ea typeface="Noto Sans" pitchFamily="34" charset="-122"/>
@@ -4731,7 +4731,7 @@
               </a:rPr>
               <a:t>最新提交：2025-08-26</a:t>
             </a:r>
-            <a:endParaRPr lang="en-US" sz="900" dirty="0"/>
+            <a:endParaRPr lang="en-US" sz="950" dirty="0"/>
           </a:p>
         </p:txBody>
       </p:sp>
@@ -6298,8 +6298,8 @@
         </p:nvSpPr>
         <p:spPr>
           <a:xfrm>
-            <a:off x="7754112" y="2432304"/>
-            <a:ext cx="685800" cy="530352"/>
+            <a:off x="7818120" y="2432304"/>
+            <a:ext cx="658368" cy="530352"/>
           </a:xfrm>
           <a:prstGeom prst="roundRect">
             <a:avLst/>
@@ -6325,8 +6325,8 @@
         </p:nvSpPr>
         <p:spPr>
           <a:xfrm>
-            <a:off x="7754112" y="2432304"/>
-            <a:ext cx="685800" cy="530352"/>
+            <a:off x="7818120" y="2432304"/>
+            <a:ext cx="658368" cy="530352"/>
           </a:xfrm>
           <a:prstGeom prst="rect">
             <a:avLst/>
@@ -6366,8 +6366,8 @@
         </p:nvSpPr>
         <p:spPr>
           <a:xfrm>
-            <a:off x="8604504" y="2432304"/>
-            <a:ext cx="685800" cy="530352"/>
+            <a:off x="8650224" y="2432304"/>
+            <a:ext cx="658368" cy="530352"/>
           </a:xfrm>
           <a:prstGeom prst="roundRect">
             <a:avLst/>
@@ -6393,8 +6393,8 @@
         </p:nvSpPr>
         <p:spPr>
           <a:xfrm>
-            <a:off x="8604504" y="2432304"/>
-            <a:ext cx="685800" cy="530352"/>
+            <a:off x="8650224" y="2432304"/>
+            <a:ext cx="658368" cy="530352"/>
           </a:xfrm>
           <a:prstGeom prst="rect">
             <a:avLst/>
@@ -6434,8 +6434,8 @@
         </p:nvSpPr>
         <p:spPr>
           <a:xfrm>
-            <a:off x="9454896" y="2432304"/>
-            <a:ext cx="685800" cy="530352"/>
+            <a:off x="9482328" y="2432304"/>
+            <a:ext cx="658368" cy="530352"/>
           </a:xfrm>
           <a:prstGeom prst="roundRect">
             <a:avLst/>
@@ -6461,8 +6461,8 @@
         </p:nvSpPr>
         <p:spPr>
           <a:xfrm>
-            <a:off x="9454896" y="2432304"/>
-            <a:ext cx="685800" cy="530352"/>
+            <a:off x="9482328" y="2432304"/>
+            <a:ext cx="658368" cy="530352"/>
           </a:xfrm>
           <a:prstGeom prst="rect">
             <a:avLst/>
@@ -6502,8 +6502,8 @@
         </p:nvSpPr>
         <p:spPr>
           <a:xfrm>
-            <a:off x="10305288" y="2432304"/>
-            <a:ext cx="685800" cy="530352"/>
+            <a:off x="10314432" y="2432304"/>
+            <a:ext cx="658368" cy="530352"/>
           </a:xfrm>
           <a:prstGeom prst="roundRect">
             <a:avLst/>
@@ -6529,8 +6529,8 @@
         </p:nvSpPr>
         <p:spPr>
           <a:xfrm>
-            <a:off x="10305288" y="2432304"/>
-            <a:ext cx="685800" cy="530352"/>
+            <a:off x="10314432" y="2432304"/>
+            <a:ext cx="658368" cy="530352"/>
           </a:xfrm>
           <a:prstGeom prst="rect">
             <a:avLst/>
@@ -6570,8 +6570,8 @@
         </p:nvSpPr>
         <p:spPr>
           <a:xfrm>
-            <a:off x="7754112" y="3246120"/>
-            <a:ext cx="950976" cy="530352"/>
+            <a:off x="8119872" y="3246120"/>
+            <a:ext cx="877824" cy="530352"/>
           </a:xfrm>
           <a:prstGeom prst="roundRect">
             <a:avLst/>
@@ -6597,8 +6597,8 @@
         </p:nvSpPr>
         <p:spPr>
           <a:xfrm>
-            <a:off x="7754112" y="3246120"/>
-            <a:ext cx="950976" cy="530352"/>
+            <a:off x="8119872" y="3246120"/>
+            <a:ext cx="877824" cy="530352"/>
           </a:xfrm>
           <a:prstGeom prst="rect">
             <a:avLst/>
@@ -6638,8 +6638,8 @@
         </p:nvSpPr>
         <p:spPr>
           <a:xfrm>
-            <a:off x="8869680" y="3246120"/>
-            <a:ext cx="950976" cy="530352"/>
+            <a:off x="9107424" y="3246120"/>
+            <a:ext cx="877824" cy="530352"/>
           </a:xfrm>
           <a:prstGeom prst="roundRect">
             <a:avLst/>
@@ -6665,8 +6665,8 @@
         </p:nvSpPr>
         <p:spPr>
           <a:xfrm>
-            <a:off x="8869680" y="3246120"/>
-            <a:ext cx="950976" cy="530352"/>
+            <a:off x="9107424" y="3246120"/>
+            <a:ext cx="877824" cy="530352"/>
           </a:xfrm>
           <a:prstGeom prst="rect">
             <a:avLst/>
@@ -6706,8 +6706,8 @@
         </p:nvSpPr>
         <p:spPr>
           <a:xfrm>
-            <a:off x="9985248" y="3246120"/>
-            <a:ext cx="950976" cy="530352"/>
+            <a:off x="10094976" y="3246120"/>
+            <a:ext cx="877824" cy="530352"/>
           </a:xfrm>
           <a:prstGeom prst="roundRect">
             <a:avLst/>
@@ -6733,8 +6733,8 @@
         </p:nvSpPr>
         <p:spPr>
           <a:xfrm>
-            <a:off x="9985248" y="3246120"/>
-            <a:ext cx="950976" cy="530352"/>
+            <a:off x="10094976" y="3246120"/>
+            <a:ext cx="877824" cy="530352"/>
           </a:xfrm>
           <a:prstGeom prst="rect">
             <a:avLst/>
@@ -7309,7 +7309,7 @@
             <a:r>
               <a:rPr lang="en-US" sz="2400" b="1" dirty="0">
                 <a:solidFill>
-                  <a:srgbClr val="B8D6DB"/>
+                  <a:srgbClr val="8EB6C1"/>
                 </a:solidFill>
                 <a:latin typeface="Noto Serif" pitchFamily="34" charset="0"/>
                 <a:ea typeface="Noto Serif" pitchFamily="34" charset="-122"/>
@@ -7532,7 +7532,7 @@
             <a:r>
               <a:rPr lang="en-US" sz="2400" b="1" dirty="0">
                 <a:solidFill>
-                  <a:srgbClr val="B8D6DB"/>
+                  <a:srgbClr val="8EB6C1"/>
                 </a:solidFill>
                 <a:latin typeface="Noto Serif" pitchFamily="34" charset="0"/>
                 <a:ea typeface="Noto Serif" pitchFamily="34" charset="-122"/>
@@ -7755,7 +7755,7 @@
             <a:r>
               <a:rPr lang="en-US" sz="2400" b="1" dirty="0">
                 <a:solidFill>
-                  <a:srgbClr val="B8D6DB"/>
+                  <a:srgbClr val="8EB6C1"/>
                 </a:solidFill>
                 <a:latin typeface="Noto Serif" pitchFamily="34" charset="0"/>
                 <a:ea typeface="Noto Serif" pitchFamily="34" charset="-122"/>
@@ -7978,7 +7978,7 @@
             <a:r>
               <a:rPr lang="en-US" sz="2400" b="1" dirty="0">
                 <a:solidFill>
-                  <a:srgbClr val="B8D6DB"/>
+                  <a:srgbClr val="8EB6C1"/>
                 </a:solidFill>
                 <a:latin typeface="Noto Serif" pitchFamily="34" charset="0"/>
                 <a:ea typeface="Noto Serif" pitchFamily="34" charset="-122"/>
@@ -10346,9 +10346,9 @@
               <a:buNone/>
             </a:pPr>
             <a:r>
-              <a:rPr lang="en-US" sz="1000" dirty="0">
-                <a:solidFill>
-                  <a:srgbClr val="6B7C8F"/>
+              <a:rPr lang="en-US" sz="1050" dirty="0">
+                <a:solidFill>
+                  <a:srgbClr val="334E68"/>
                 </a:solidFill>
                 <a:latin typeface="Noto Sans" pitchFamily="34" charset="0"/>
                 <a:ea typeface="Noto Sans" pitchFamily="34" charset="-122"/>
@@ -10356,7 +10356,7 @@
               </a:rPr>
               <a:t>生成 / 编辑 / 部署 / 管理</a:t>
             </a:r>
-            <a:endParaRPr lang="en-US" sz="1000" dirty="0"/>
+            <a:endParaRPr lang="en-US" sz="1050" dirty="0"/>
           </a:p>
         </p:txBody>
       </p:sp>
@@ -10482,9 +10482,9 @@
               <a:buNone/>
             </a:pPr>
             <a:r>
-              <a:rPr lang="en-US" sz="1000" dirty="0">
-                <a:solidFill>
-                  <a:srgbClr val="6B7C8F"/>
+              <a:rPr lang="en-US" sz="1050" dirty="0">
+                <a:solidFill>
+                  <a:srgbClr val="334E68"/>
                 </a:solidFill>
                 <a:latin typeface="Noto Sans" pitchFamily="34" charset="0"/>
                 <a:ea typeface="Noto Sans" pitchFamily="34" charset="-122"/>
@@ -10492,7 +10492,7 @@
               </a:rPr>
               <a:t>单体 + 微服务 + 监控</a:t>
             </a:r>
-            <a:endParaRPr lang="en-US" sz="1000" dirty="0"/>
+            <a:endParaRPr lang="en-US" sz="1050" dirty="0"/>
           </a:p>
         </p:txBody>
       </p:sp>
@@ -10618,9 +10618,9 @@
               <a:buNone/>
             </a:pPr>
             <a:r>
-              <a:rPr lang="en-US" sz="1000" dirty="0">
-                <a:solidFill>
-                  <a:srgbClr val="6B7C8F"/>
+              <a:rPr lang="en-US" sz="1050" dirty="0">
+                <a:solidFill>
+                  <a:srgbClr val="334E68"/>
                 </a:solidFill>
                 <a:latin typeface="Noto Sans" pitchFamily="34" charset="0"/>
                 <a:ea typeface="Noto Sans" pitchFamily="34" charset="-122"/>
@@ -10628,7 +10628,7 @@
               </a:rPr>
               <a:t>有后端测试，无前端测试</a:t>
             </a:r>
-            <a:endParaRPr lang="en-US" sz="1000" dirty="0"/>
+            <a:endParaRPr lang="en-US" sz="1050" dirty="0"/>
           </a:p>
         </p:txBody>
       </p:sp>
@@ -10754,9 +10754,9 @@
               <a:buNone/>
             </a:pPr>
             <a:r>
-              <a:rPr lang="en-US" sz="1000" dirty="0">
-                <a:solidFill>
-                  <a:srgbClr val="6B7C8F"/>
+              <a:rPr lang="en-US" sz="1050" dirty="0">
+                <a:solidFill>
+                  <a:srgbClr val="334E68"/>
                 </a:solidFill>
                 <a:latin typeface="Noto Sans" pitchFamily="34" charset="0"/>
                 <a:ea typeface="Noto Sans" pitchFamily="34" charset="-122"/>
@@ -10764,7 +10764,7 @@
               </a:rPr>
               <a:t>未发现 CI 配置</a:t>
             </a:r>
-            <a:endParaRPr lang="en-US" sz="1000" dirty="0"/>
+            <a:endParaRPr lang="en-US" sz="1050" dirty="0"/>
           </a:p>
         </p:txBody>
       </p:sp>
@@ -11758,7 +11758,7 @@
                 <a:ea typeface="Noto Sans" pitchFamily="34" charset="-122"/>
                 <a:cs typeface="Noto Sans" pitchFamily="34" charset="-120"/>
               </a:rPr>
-              <a:t>依赖模型 API、MySQL、Redis、Nacos、COS、浏览器</a:t>
+              <a:t>模型 API、MySQL / Redis / Nacos、COS 与浏览器</a:t>
             </a:r>
             <a:endParaRPr lang="en-US" sz="1200" dirty="0"/>
           </a:p>
@@ -12830,7 +12830,7 @@
         <p:spPr>
           <a:xfrm>
             <a:off x="1298448" y="3063240"/>
-            <a:ext cx="2304288" cy="438912"/>
+            <a:ext cx="2395728" cy="438912"/>
           </a:xfrm>
           <a:prstGeom prst="rect">
             <a:avLst/>
@@ -12848,7 +12848,7 @@
               <a:buNone/>
             </a:pPr>
             <a:r>
-              <a:rPr lang="en-US" sz="1250" dirty="0">
+              <a:rPr lang="en-US" sz="1150" dirty="0">
                 <a:solidFill>
                   <a:srgbClr val="334E68"/>
                 </a:solidFill>
@@ -12858,7 +12858,7 @@
               </a:rPr>
               <a:t>15 个后端测试类</a:t>
             </a:r>
-            <a:endParaRPr lang="en-US" sz="1250" dirty="0"/>
+            <a:endParaRPr lang="en-US" sz="1150" dirty="0"/>
           </a:p>
         </p:txBody>
       </p:sp>
@@ -12898,7 +12898,7 @@
         <p:spPr>
           <a:xfrm>
             <a:off x="1298448" y="3749040"/>
-            <a:ext cx="2304288" cy="438912"/>
+            <a:ext cx="2395728" cy="438912"/>
           </a:xfrm>
           <a:prstGeom prst="rect">
             <a:avLst/>
@@ -12916,7 +12916,7 @@
               <a:buNone/>
             </a:pPr>
             <a:r>
-              <a:rPr lang="en-US" sz="1250" dirty="0">
+              <a:rPr lang="en-US" sz="1150" dirty="0">
                 <a:solidFill>
                   <a:srgbClr val="334E68"/>
                 </a:solidFill>
@@ -12924,9 +12924,9 @@
                 <a:ea typeface="Noto Sans" pitchFamily="34" charset="-122"/>
                 <a:cs typeface="Noto Sans" pitchFamily="34" charset="-120"/>
               </a:rPr>
-              <a:t>包含代码解析、AI 路由、工作流、截图工具</a:t>
-            </a:r>
-            <a:endParaRPr lang="en-US" sz="1250" dirty="0"/>
+              <a:t>覆盖解析、路由、工作流、截图</a:t>
+            </a:r>
+            <a:endParaRPr lang="en-US" sz="1150" dirty="0"/>
           </a:p>
         </p:txBody>
       </p:sp>
@@ -12966,7 +12966,7 @@
         <p:spPr>
           <a:xfrm>
             <a:off x="1298448" y="4434840"/>
-            <a:ext cx="2304288" cy="438912"/>
+            <a:ext cx="2395728" cy="438912"/>
           </a:xfrm>
           <a:prstGeom prst="rect">
             <a:avLst/>
@@ -12984,7 +12984,7 @@
               <a:buNone/>
             </a:pPr>
             <a:r>
-              <a:rPr lang="en-US" sz="1250" dirty="0">
+              <a:rPr lang="en-US" sz="1150" dirty="0">
                 <a:solidFill>
                   <a:srgbClr val="334E68"/>
                 </a:solidFill>
@@ -12994,7 +12994,7 @@
               </a:rPr>
               <a:t>多数为 SpringBootTest，依赖外部环境</a:t>
             </a:r>
-            <a:endParaRPr lang="en-US" sz="1250" dirty="0"/>
+            <a:endParaRPr lang="en-US" sz="1150" dirty="0"/>
           </a:p>
         </p:txBody>
       </p:sp>
@@ -13245,7 +13245,7 @@
         <p:spPr>
           <a:xfrm>
             <a:off x="4956048" y="3063240"/>
-            <a:ext cx="2304288" cy="438912"/>
+            <a:ext cx="2395728" cy="438912"/>
           </a:xfrm>
           <a:prstGeom prst="rect">
             <a:avLst/>
@@ -13263,7 +13263,7 @@
               <a:buNone/>
             </a:pPr>
             <a:r>
-              <a:rPr lang="en-US" sz="1250" dirty="0">
+              <a:rPr lang="en-US" sz="1150" dirty="0">
                 <a:solidFill>
                   <a:srgbClr val="334E68"/>
                 </a:solidFill>
@@ -13273,7 +13273,7 @@
               </a:rPr>
               <a:t>Spring Actuator + Micrometer</a:t>
             </a:r>
-            <a:endParaRPr lang="en-US" sz="1250" dirty="0"/>
+            <a:endParaRPr lang="en-US" sz="1150" dirty="0"/>
           </a:p>
         </p:txBody>
       </p:sp>
@@ -13313,7 +13313,7 @@
         <p:spPr>
           <a:xfrm>
             <a:off x="4956048" y="3749040"/>
-            <a:ext cx="2304288" cy="438912"/>
+            <a:ext cx="2395728" cy="438912"/>
           </a:xfrm>
           <a:prstGeom prst="rect">
             <a:avLst/>
@@ -13331,7 +13331,7 @@
               <a:buNone/>
             </a:pPr>
             <a:r>
-              <a:rPr lang="en-US" sz="1250" dirty="0">
+              <a:rPr lang="en-US" sz="1150" dirty="0">
                 <a:solidFill>
                   <a:srgbClr val="334E68"/>
                 </a:solidFill>
@@ -13341,7 +13341,7 @@
               </a:rPr>
               <a:t>Prometheus 指标采集</a:t>
             </a:r>
-            <a:endParaRPr lang="en-US" sz="1250" dirty="0"/>
+            <a:endParaRPr lang="en-US" sz="1150" dirty="0"/>
           </a:p>
         </p:txBody>
       </p:sp>
@@ -13381,7 +13381,7 @@
         <p:spPr>
           <a:xfrm>
             <a:off x="4956048" y="4434840"/>
-            <a:ext cx="2304288" cy="438912"/>
+            <a:ext cx="2395728" cy="438912"/>
           </a:xfrm>
           <a:prstGeom prst="rect">
             <a:avLst/>
@@ -13399,7 +13399,7 @@
               <a:buNone/>
             </a:pPr>
             <a:r>
-              <a:rPr lang="en-US" sz="1250" dirty="0">
+              <a:rPr lang="en-US" sz="1150" dirty="0">
                 <a:solidFill>
                   <a:srgbClr val="334E68"/>
                 </a:solidFill>
@@ -13409,7 +13409,7 @@
               </a:rPr>
               <a:t>Grafana AI 模型面板配置</a:t>
             </a:r>
-            <a:endParaRPr lang="en-US" sz="1250" dirty="0"/>
+            <a:endParaRPr lang="en-US" sz="1150" dirty="0"/>
           </a:p>
         </p:txBody>
       </p:sp>
@@ -13658,7 +13658,7 @@
         <p:spPr>
           <a:xfrm>
             <a:off x="8613648" y="3063240"/>
-            <a:ext cx="2304288" cy="438912"/>
+            <a:ext cx="2395728" cy="438912"/>
           </a:xfrm>
           <a:prstGeom prst="rect">
             <a:avLst/>
@@ -13676,7 +13676,7 @@
               <a:buNone/>
             </a:pPr>
             <a:r>
-              <a:rPr lang="en-US" sz="1250" dirty="0">
+              <a:rPr lang="en-US" sz="1150" dirty="0">
                 <a:solidFill>
                   <a:srgbClr val="334E68"/>
                 </a:solidFill>
@@ -13686,7 +13686,7 @@
               </a:rPr>
               <a:t>未发现 CI 工作流</a:t>
             </a:r>
-            <a:endParaRPr lang="en-US" sz="1250" dirty="0"/>
+            <a:endParaRPr lang="en-US" sz="1150" dirty="0"/>
           </a:p>
         </p:txBody>
       </p:sp>
@@ -13726,7 +13726,7 @@
         <p:spPr>
           <a:xfrm>
             <a:off x="8613648" y="3749040"/>
-            <a:ext cx="2304288" cy="438912"/>
+            <a:ext cx="2395728" cy="438912"/>
           </a:xfrm>
           <a:prstGeom prst="rect">
             <a:avLst/>
@@ -13744,7 +13744,7 @@
               <a:buNone/>
             </a:pPr>
             <a:r>
-              <a:rPr lang="en-US" sz="1250" dirty="0">
+              <a:rPr lang="en-US" sz="1150" dirty="0">
                 <a:solidFill>
                   <a:srgbClr val="334E68"/>
                 </a:solidFill>
@@ -13754,7 +13754,7 @@
               </a:rPr>
               <a:t>前端无自动化测试文件</a:t>
             </a:r>
-            <a:endParaRPr lang="en-US" sz="1250" dirty="0"/>
+            <a:endParaRPr lang="en-US" sz="1150" dirty="0"/>
           </a:p>
         </p:txBody>
       </p:sp>
@@ -13794,7 +13794,7 @@
         <p:spPr>
           <a:xfrm>
             <a:off x="8613648" y="4434840"/>
-            <a:ext cx="2304288" cy="438912"/>
+            <a:ext cx="2395728" cy="438912"/>
           </a:xfrm>
           <a:prstGeom prst="rect">
             <a:avLst/>
@@ -13812,7 +13812,7 @@
               <a:buNone/>
             </a:pPr>
             <a:r>
-              <a:rPr lang="en-US" sz="1250" dirty="0">
+              <a:rPr lang="en-US" sz="1150" dirty="0">
                 <a:solidFill>
                   <a:srgbClr val="334E68"/>
                 </a:solidFill>
@@ -13822,7 +13822,7 @@
               </a:rPr>
               <a:t>没有近期流水线状态可核验</a:t>
             </a:r>
-            <a:endParaRPr lang="en-US" sz="1250" dirty="0"/>
+            <a:endParaRPr lang="en-US" sz="1150" dirty="0"/>
           </a:p>
         </p:txBody>
       </p:sp>
@@ -14958,11 +14958,11 @@
             <a:avLst/>
           </a:prstGeom>
           <a:solidFill>
-            <a:srgbClr val="028090"/>
+            <a:srgbClr val="F4B942"/>
           </a:solidFill>
           <a:ln w="12700">
             <a:solidFill>
-              <a:srgbClr val="028090">
+              <a:srgbClr val="F4B942">
                 <a:alpha val="0"/>
               </a:srgbClr>
             </a:solidFill>

</xml_diff>

<commit_message>
docs: improve report contrast and alignment
Co-authored-by: 程序员鱼皮 <592789970@qq.com>
</commit_message>
<xml_diff>
--- a/docs/reports/project-status-2026-07-23.pptx
+++ b/docs/reports/project-status-2026-07-23.pptx
@@ -3624,7 +3624,7 @@
         <p:spPr>
           <a:xfrm>
             <a:off x="658368" y="310896"/>
-            <a:ext cx="2011680" cy="228600"/>
+            <a:ext cx="3108960" cy="228600"/>
           </a:xfrm>
           <a:prstGeom prst="rect">
             <a:avLst/>
@@ -4175,9 +4175,9 @@
               <a:buNone/>
             </a:pPr>
             <a:r>
-              <a:rPr lang="en-US" sz="950" dirty="0">
-                <a:solidFill>
-                  <a:srgbClr val="334E68"/>
+              <a:rPr lang="en-US" sz="1050" dirty="0">
+                <a:solidFill>
+                  <a:srgbClr val="16324F"/>
                 </a:solidFill>
                 <a:latin typeface="Noto Sans" pitchFamily="34" charset="0"/>
                 <a:ea typeface="Noto Sans" pitchFamily="34" charset="-122"/>
@@ -4185,7 +4185,7 @@
               </a:rPr>
               <a:t>common / model / client / user / app / ai / screenshot</a:t>
             </a:r>
-            <a:endParaRPr lang="en-US" sz="950" dirty="0"/>
+            <a:endParaRPr lang="en-US" sz="1050" dirty="0"/>
           </a:p>
         </p:txBody>
       </p:sp>
@@ -4357,9 +4357,9 @@
               <a:buNone/>
             </a:pPr>
             <a:r>
-              <a:rPr lang="en-US" sz="950" dirty="0">
-                <a:solidFill>
-                  <a:srgbClr val="334E68"/>
+              <a:rPr lang="en-US" sz="1050" dirty="0">
+                <a:solidFill>
+                  <a:srgbClr val="16324F"/>
                 </a:solidFill>
                 <a:latin typeface="Noto Sans" pitchFamily="34" charset="0"/>
                 <a:ea typeface="Noto Sans" pitchFamily="34" charset="-122"/>
@@ -4367,7 +4367,7 @@
               </a:rPr>
               <a:t>单体与微服务代码合计</a:t>
             </a:r>
-            <a:endParaRPr lang="en-US" sz="950" dirty="0"/>
+            <a:endParaRPr lang="en-US" sz="1050" dirty="0"/>
           </a:p>
         </p:txBody>
       </p:sp>
@@ -4539,9 +4539,9 @@
               <a:buNone/>
             </a:pPr>
             <a:r>
-              <a:rPr lang="en-US" sz="950" dirty="0">
-                <a:solidFill>
-                  <a:srgbClr val="334E68"/>
+              <a:rPr lang="en-US" sz="1050" dirty="0">
+                <a:solidFill>
+                  <a:srgbClr val="16324F"/>
                 </a:solidFill>
                 <a:latin typeface="Noto Sans" pitchFamily="34" charset="0"/>
                 <a:ea typeface="Noto Sans" pitchFamily="34" charset="-122"/>
@@ -4549,7 +4549,7 @@
               </a:rPr>
               <a:t>Vue 3 + TypeScript + Ant Design Vue</a:t>
             </a:r>
-            <a:endParaRPr lang="en-US" sz="950" dirty="0"/>
+            <a:endParaRPr lang="en-US" sz="1050" dirty="0"/>
           </a:p>
         </p:txBody>
       </p:sp>
@@ -4721,9 +4721,9 @@
               <a:buNone/>
             </a:pPr>
             <a:r>
-              <a:rPr lang="en-US" sz="950" dirty="0">
-                <a:solidFill>
-                  <a:srgbClr val="334E68"/>
+              <a:rPr lang="en-US" sz="1050" dirty="0">
+                <a:solidFill>
+                  <a:srgbClr val="16324F"/>
                 </a:solidFill>
                 <a:latin typeface="Noto Sans" pitchFamily="34" charset="0"/>
                 <a:ea typeface="Noto Sans" pitchFamily="34" charset="-122"/>
@@ -4731,7 +4731,7 @@
               </a:rPr>
               <a:t>最新提交：2025-08-26</a:t>
             </a:r>
-            <a:endParaRPr lang="en-US" sz="950" dirty="0"/>
+            <a:endParaRPr lang="en-US" sz="1050" dirty="0"/>
           </a:p>
         </p:txBody>
       </p:sp>
@@ -5033,7 +5033,7 @@
         <p:spPr>
           <a:xfrm>
             <a:off x="658368" y="310896"/>
-            <a:ext cx="2011680" cy="228600"/>
+            <a:ext cx="3108960" cy="228600"/>
           </a:xfrm>
           <a:prstGeom prst="rect">
             <a:avLst/>
@@ -6299,7 +6299,7 @@
         <p:spPr>
           <a:xfrm>
             <a:off x="7818120" y="2432304"/>
-            <a:ext cx="658368" cy="530352"/>
+            <a:ext cx="731520" cy="530352"/>
           </a:xfrm>
           <a:prstGeom prst="roundRect">
             <a:avLst/>
@@ -6326,7 +6326,7 @@
         <p:spPr>
           <a:xfrm>
             <a:off x="7818120" y="2432304"/>
-            <a:ext cx="658368" cy="530352"/>
+            <a:ext cx="731520" cy="530352"/>
           </a:xfrm>
           <a:prstGeom prst="rect">
             <a:avLst/>
@@ -6366,8 +6366,8 @@
         </p:nvSpPr>
         <p:spPr>
           <a:xfrm>
-            <a:off x="8650224" y="2432304"/>
-            <a:ext cx="658368" cy="530352"/>
+            <a:off x="8659368" y="2432304"/>
+            <a:ext cx="731520" cy="530352"/>
           </a:xfrm>
           <a:prstGeom prst="roundRect">
             <a:avLst/>
@@ -6393,8 +6393,8 @@
         </p:nvSpPr>
         <p:spPr>
           <a:xfrm>
-            <a:off x="8650224" y="2432304"/>
-            <a:ext cx="658368" cy="530352"/>
+            <a:off x="8659368" y="2432304"/>
+            <a:ext cx="731520" cy="530352"/>
           </a:xfrm>
           <a:prstGeom prst="rect">
             <a:avLst/>
@@ -6434,8 +6434,8 @@
         </p:nvSpPr>
         <p:spPr>
           <a:xfrm>
-            <a:off x="9482328" y="2432304"/>
-            <a:ext cx="658368" cy="530352"/>
+            <a:off x="9500616" y="2432304"/>
+            <a:ext cx="731520" cy="530352"/>
           </a:xfrm>
           <a:prstGeom prst="roundRect">
             <a:avLst/>
@@ -6461,8 +6461,8 @@
         </p:nvSpPr>
         <p:spPr>
           <a:xfrm>
-            <a:off x="9482328" y="2432304"/>
-            <a:ext cx="658368" cy="530352"/>
+            <a:off x="9500616" y="2432304"/>
+            <a:ext cx="731520" cy="530352"/>
           </a:xfrm>
           <a:prstGeom prst="rect">
             <a:avLst/>
@@ -6502,8 +6502,8 @@
         </p:nvSpPr>
         <p:spPr>
           <a:xfrm>
-            <a:off x="10314432" y="2432304"/>
-            <a:ext cx="658368" cy="530352"/>
+            <a:off x="10341864" y="2432304"/>
+            <a:ext cx="731520" cy="530352"/>
           </a:xfrm>
           <a:prstGeom prst="roundRect">
             <a:avLst/>
@@ -6529,8 +6529,8 @@
         </p:nvSpPr>
         <p:spPr>
           <a:xfrm>
-            <a:off x="10314432" y="2432304"/>
-            <a:ext cx="658368" cy="530352"/>
+            <a:off x="10341864" y="2432304"/>
+            <a:ext cx="731520" cy="530352"/>
           </a:xfrm>
           <a:prstGeom prst="rect">
             <a:avLst/>
@@ -6570,8 +6570,8 @@
         </p:nvSpPr>
         <p:spPr>
           <a:xfrm>
-            <a:off x="8119872" y="3246120"/>
-            <a:ext cx="877824" cy="530352"/>
+            <a:off x="8028432" y="3246120"/>
+            <a:ext cx="932688" cy="530352"/>
           </a:xfrm>
           <a:prstGeom prst="roundRect">
             <a:avLst/>
@@ -6597,8 +6597,8 @@
         </p:nvSpPr>
         <p:spPr>
           <a:xfrm>
-            <a:off x="8119872" y="3246120"/>
-            <a:ext cx="877824" cy="530352"/>
+            <a:off x="8028432" y="3246120"/>
+            <a:ext cx="932688" cy="530352"/>
           </a:xfrm>
           <a:prstGeom prst="rect">
             <a:avLst/>
@@ -6638,8 +6638,8 @@
         </p:nvSpPr>
         <p:spPr>
           <a:xfrm>
-            <a:off x="9107424" y="3246120"/>
-            <a:ext cx="877824" cy="530352"/>
+            <a:off x="9052560" y="3246120"/>
+            <a:ext cx="932688" cy="530352"/>
           </a:xfrm>
           <a:prstGeom prst="roundRect">
             <a:avLst/>
@@ -6665,8 +6665,8 @@
         </p:nvSpPr>
         <p:spPr>
           <a:xfrm>
-            <a:off x="9107424" y="3246120"/>
-            <a:ext cx="877824" cy="530352"/>
+            <a:off x="9052560" y="3246120"/>
+            <a:ext cx="932688" cy="530352"/>
           </a:xfrm>
           <a:prstGeom prst="rect">
             <a:avLst/>
@@ -6706,8 +6706,8 @@
         </p:nvSpPr>
         <p:spPr>
           <a:xfrm>
-            <a:off x="10094976" y="3246120"/>
-            <a:ext cx="877824" cy="530352"/>
+            <a:off x="10076688" y="3246120"/>
+            <a:ext cx="932688" cy="530352"/>
           </a:xfrm>
           <a:prstGeom prst="roundRect">
             <a:avLst/>
@@ -6733,8 +6733,8 @@
         </p:nvSpPr>
         <p:spPr>
           <a:xfrm>
-            <a:off x="10094976" y="3246120"/>
-            <a:ext cx="877824" cy="530352"/>
+            <a:off x="10076688" y="3246120"/>
+            <a:ext cx="932688" cy="530352"/>
           </a:xfrm>
           <a:prstGeom prst="rect">
             <a:avLst/>
@@ -7039,7 +7039,7 @@
         <p:spPr>
           <a:xfrm>
             <a:off x="658368" y="310896"/>
-            <a:ext cx="2011680" cy="228600"/>
+            <a:ext cx="3108960" cy="228600"/>
           </a:xfrm>
           <a:prstGeom prst="rect">
             <a:avLst/>
@@ -7309,7 +7309,7 @@
             <a:r>
               <a:rPr lang="en-US" sz="2400" b="1" dirty="0">
                 <a:solidFill>
-                  <a:srgbClr val="8EB6C1"/>
+                  <a:srgbClr val="5D93A2"/>
                 </a:solidFill>
                 <a:latin typeface="Noto Serif" pitchFamily="34" charset="0"/>
                 <a:ea typeface="Noto Serif" pitchFamily="34" charset="-122"/>
@@ -7532,7 +7532,7 @@
             <a:r>
               <a:rPr lang="en-US" sz="2400" b="1" dirty="0">
                 <a:solidFill>
-                  <a:srgbClr val="8EB6C1"/>
+                  <a:srgbClr val="5D93A2"/>
                 </a:solidFill>
                 <a:latin typeface="Noto Serif" pitchFamily="34" charset="0"/>
                 <a:ea typeface="Noto Serif" pitchFamily="34" charset="-122"/>
@@ -7755,7 +7755,7 @@
             <a:r>
               <a:rPr lang="en-US" sz="2400" b="1" dirty="0">
                 <a:solidFill>
-                  <a:srgbClr val="8EB6C1"/>
+                  <a:srgbClr val="5D93A2"/>
                 </a:solidFill>
                 <a:latin typeface="Noto Serif" pitchFamily="34" charset="0"/>
                 <a:ea typeface="Noto Serif" pitchFamily="34" charset="-122"/>
@@ -7978,7 +7978,7 @@
             <a:r>
               <a:rPr lang="en-US" sz="2400" b="1" dirty="0">
                 <a:solidFill>
-                  <a:srgbClr val="8EB6C1"/>
+                  <a:srgbClr val="5D93A2"/>
                 </a:solidFill>
                 <a:latin typeface="Noto Serif" pitchFamily="34" charset="0"/>
                 <a:ea typeface="Noto Serif" pitchFamily="34" charset="-122"/>
@@ -8195,7 +8195,7 @@
         <p:spPr>
           <a:xfrm>
             <a:off x="658368" y="310896"/>
-            <a:ext cx="2011680" cy="228600"/>
+            <a:ext cx="3108960" cy="228600"/>
           </a:xfrm>
           <a:prstGeom prst="rect">
             <a:avLst/>
@@ -9459,7 +9459,7 @@
         <p:spPr>
           <a:xfrm>
             <a:off x="658368" y="310896"/>
-            <a:ext cx="2011680" cy="228600"/>
+            <a:ext cx="3108960" cy="228600"/>
           </a:xfrm>
           <a:prstGeom prst="rect">
             <a:avLst/>
@@ -10346,9 +10346,9 @@
               <a:buNone/>
             </a:pPr>
             <a:r>
-              <a:rPr lang="en-US" sz="1050" dirty="0">
-                <a:solidFill>
-                  <a:srgbClr val="334E68"/>
+              <a:rPr lang="en-US" sz="1100" dirty="0">
+                <a:solidFill>
+                  <a:srgbClr val="16324F"/>
                 </a:solidFill>
                 <a:latin typeface="Noto Sans" pitchFamily="34" charset="0"/>
                 <a:ea typeface="Noto Sans" pitchFamily="34" charset="-122"/>
@@ -10356,7 +10356,7 @@
               </a:rPr>
               <a:t>生成 / 编辑 / 部署 / 管理</a:t>
             </a:r>
-            <a:endParaRPr lang="en-US" sz="1050" dirty="0"/>
+            <a:endParaRPr lang="en-US" sz="1100" dirty="0"/>
           </a:p>
         </p:txBody>
       </p:sp>
@@ -10482,9 +10482,9 @@
               <a:buNone/>
             </a:pPr>
             <a:r>
-              <a:rPr lang="en-US" sz="1050" dirty="0">
-                <a:solidFill>
-                  <a:srgbClr val="334E68"/>
+              <a:rPr lang="en-US" sz="1100" dirty="0">
+                <a:solidFill>
+                  <a:srgbClr val="16324F"/>
                 </a:solidFill>
                 <a:latin typeface="Noto Sans" pitchFamily="34" charset="0"/>
                 <a:ea typeface="Noto Sans" pitchFamily="34" charset="-122"/>
@@ -10492,7 +10492,7 @@
               </a:rPr>
               <a:t>单体 + 微服务 + 监控</a:t>
             </a:r>
-            <a:endParaRPr lang="en-US" sz="1050" dirty="0"/>
+            <a:endParaRPr lang="en-US" sz="1100" dirty="0"/>
           </a:p>
         </p:txBody>
       </p:sp>
@@ -10618,9 +10618,9 @@
               <a:buNone/>
             </a:pPr>
             <a:r>
-              <a:rPr lang="en-US" sz="1050" dirty="0">
-                <a:solidFill>
-                  <a:srgbClr val="334E68"/>
+              <a:rPr lang="en-US" sz="1100" dirty="0">
+                <a:solidFill>
+                  <a:srgbClr val="16324F"/>
                 </a:solidFill>
                 <a:latin typeface="Noto Sans" pitchFamily="34" charset="0"/>
                 <a:ea typeface="Noto Sans" pitchFamily="34" charset="-122"/>
@@ -10628,7 +10628,7 @@
               </a:rPr>
               <a:t>有后端测试，无前端测试</a:t>
             </a:r>
-            <a:endParaRPr lang="en-US" sz="1050" dirty="0"/>
+            <a:endParaRPr lang="en-US" sz="1100" dirty="0"/>
           </a:p>
         </p:txBody>
       </p:sp>
@@ -10754,9 +10754,9 @@
               <a:buNone/>
             </a:pPr>
             <a:r>
-              <a:rPr lang="en-US" sz="1050" dirty="0">
-                <a:solidFill>
-                  <a:srgbClr val="334E68"/>
+              <a:rPr lang="en-US" sz="1100" dirty="0">
+                <a:solidFill>
+                  <a:srgbClr val="16324F"/>
                 </a:solidFill>
                 <a:latin typeface="Noto Sans" pitchFamily="34" charset="0"/>
                 <a:ea typeface="Noto Sans" pitchFamily="34" charset="-122"/>
@@ -10764,7 +10764,7 @@
               </a:rPr>
               <a:t>未发现 CI 配置</a:t>
             </a:r>
-            <a:endParaRPr lang="en-US" sz="1050" dirty="0"/>
+            <a:endParaRPr lang="en-US" sz="1100" dirty="0"/>
           </a:p>
         </p:txBody>
       </p:sp>
@@ -11054,7 +11054,7 @@
         <p:spPr>
           <a:xfrm>
             <a:off x="658368" y="310896"/>
-            <a:ext cx="2011680" cy="228600"/>
+            <a:ext cx="3108960" cy="228600"/>
           </a:xfrm>
           <a:prstGeom prst="rect">
             <a:avLst/>
@@ -12442,7 +12442,7 @@
         <p:spPr>
           <a:xfrm>
             <a:off x="658368" y="310896"/>
-            <a:ext cx="2011680" cy="228600"/>
+            <a:ext cx="3108960" cy="228600"/>
           </a:xfrm>
           <a:prstGeom prst="rect">
             <a:avLst/>
@@ -14017,7 +14017,7 @@
         <p:spPr>
           <a:xfrm>
             <a:off x="658368" y="310896"/>
-            <a:ext cx="2011680" cy="228600"/>
+            <a:ext cx="3108960" cy="228600"/>
           </a:xfrm>
           <a:prstGeom prst="rect">
             <a:avLst/>

</xml_diff>